<commit_message>
Relabel the "SHAPE" column as "IN / OUT"
Shape meant the token shape of one request - input tokens over output
tokens - which is the thing that actually sets throughput: prefill is
compute-bound, decode is memory-bandwidth-bound. It is why the mop tier
reaches 7,733 tok/s on an 8B model against 7,008 on a 120B one, since it
spends its time decoding 2,500 tokens.

None of that was legible from the word "shape", so the header now says
IN / OUT and the caption defines it. A label that needs explaining in the
room is a defect.

Co-Authored-By: Claude Opus 5 <noreply@anthropic.com>
Claude-Session: https://claude.ai/code/session_01GoqEUnvuqQuoSDLZyAdBBp
</commit_message>
<xml_diff>
--- a/deck/Vi-AI-NOC-Sizing.pptx
+++ b/deck/Vi-AI-NOC-Sizing.pptx
@@ -2585,7 +2585,7 @@
                 <a:ea typeface="IBM Plex Sans" pitchFamily="34" charset="-122"/>
                 <a:cs typeface="IBM Plex Sans" pitchFamily="34" charset="-120"/>
               </a:rPr>
-              <a:t>Measured on one H200 141GB, gated per tier. GPU column is what pan-India peak demand needs.</a:t>
+              <a:t>Measured per tier on one H200 141GB. IN / OUT = input / output tokens per request.</a:t>
             </a:r>
             <a:endParaRPr lang="en-US" sz="950" dirty="0"/>
           </a:p>
@@ -2624,7 +2624,7 @@
                 <a:ea typeface="IBM Plex Sans" pitchFamily="34" charset="-122"/>
                 <a:cs typeface="IBM Plex Sans" pitchFamily="34" charset="-120"/>
               </a:rPr>
-              <a:t>SHAPE</a:t>
+              <a:t>IN / OUT</a:t>
             </a:r>
             <a:endParaRPr lang="en-US" sz="750" dirty="0"/>
           </a:p>

</xml_diff>